<commit_message>
feat: gate entries with decision memory
</commit_message>
<xml_diff>
--- a/docs/VolGuard_Hackathon_Deck.pptx
+++ b/docs/VolGuard_Hackathon_Deck.pptx
@@ -2,18 +2,18 @@
 <file path=ppt/presentation.xml><?xml version="1.0" encoding="utf-8"?>
 <p:presentation xmlns:p="http://schemas.openxmlformats.org/presentationml/2006/main">
   <p:sldMasterIdLst>
-    <p:sldMasterId xmlns:r="http://schemas.openxmlformats.org/officeDocument/2006/relationships" id="2147483648" r:id="Ra496ff76b16a4769"/>
+    <p:sldMasterId xmlns:r="http://schemas.openxmlformats.org/officeDocument/2006/relationships" id="2147483648" r:id="R906f6eed37a84bcb"/>
   </p:sldMasterIdLst>
   <p:notesMasterIdLst>
-    <p:notesMasterId xmlns:r="http://schemas.openxmlformats.org/officeDocument/2006/relationships" r:id="R1d8026d1b4b045b0"/>
+    <p:notesMasterId xmlns:r="http://schemas.openxmlformats.org/officeDocument/2006/relationships" r:id="R0022493b20014293"/>
   </p:notesMasterIdLst>
   <p:sldIdLst>
-    <p:sldId xmlns:r="http://schemas.openxmlformats.org/officeDocument/2006/relationships" id="256" r:id="R9504c8640439455b"/>
-    <p:sldId xmlns:r="http://schemas.openxmlformats.org/officeDocument/2006/relationships" id="257" r:id="R77ff97f42562481e"/>
-    <p:sldId xmlns:r="http://schemas.openxmlformats.org/officeDocument/2006/relationships" id="258" r:id="Radb18eeb09004025"/>
-    <p:sldId xmlns:r="http://schemas.openxmlformats.org/officeDocument/2006/relationships" id="259" r:id="R70e7602e1cba47d0"/>
-    <p:sldId xmlns:r="http://schemas.openxmlformats.org/officeDocument/2006/relationships" id="260" r:id="Rf9ce5d389a964176"/>
-    <p:sldId xmlns:r="http://schemas.openxmlformats.org/officeDocument/2006/relationships" id="261" r:id="R465504e19afa4028"/>
+    <p:sldId xmlns:r="http://schemas.openxmlformats.org/officeDocument/2006/relationships" id="256" r:id="R91251f6f3cb34891"/>
+    <p:sldId xmlns:r="http://schemas.openxmlformats.org/officeDocument/2006/relationships" id="257" r:id="Rea111f5137684d9c"/>
+    <p:sldId xmlns:r="http://schemas.openxmlformats.org/officeDocument/2006/relationships" id="258" r:id="R2804b404e37d427e"/>
+    <p:sldId xmlns:r="http://schemas.openxmlformats.org/officeDocument/2006/relationships" id="259" r:id="R0d7ba71d13f04795"/>
+    <p:sldId xmlns:r="http://schemas.openxmlformats.org/officeDocument/2006/relationships" id="260" r:id="R6646b1b5adea46bf"/>
+    <p:sldId xmlns:r="http://schemas.openxmlformats.org/officeDocument/2006/relationships" id="261" r:id="R1dd889aff5114229"/>
   </p:sldIdLst>
   <p:sldSz cx="12192000" cy="6858000"/>
   <p:notesSz cx="6858000" cy="9144000"/>
@@ -537,7 +537,7 @@
           <a:lstStyle xmlns:a="http://schemas.openxmlformats.org/drawingml/2006/main"/>
           <a:p xmlns:a="http://schemas.openxmlformats.org/drawingml/2006/main">
             <a:r>
-              <a:t>Every cycle scans SPY, QQQ, IWM, and GLD. The signal model compares recent realized movement with the live at-the-money options price, then checks the session, history, paired quotes, liquidity, freshness, and edge. If any check fails, VolGuard records an abstention. No synthetic market signal is substituted.</a:t>
+              <a:t>Every cycle scans SPY, QQQ, IWM, and GLD. The signal model compares recent realized movement with the live at-the-money options price, then checks the session, history, paired quotes, liquidity, freshness, and edge. If any check fails, VolGuard records an abstention. A five-specialist council now includes Decision Memory, which requires repeated recent open-market agreement before a paper entry can pass.</a:t>
             </a:r>
           </a:p>
           <a:p xmlns:a="http://schemas.openxmlformats.org/drawingml/2006/main">
@@ -552,12 +552,17 @@
           </a:p>
           <a:p xmlns:a="http://schemas.openxmlformats.org/drawingml/2006/main">
             <a:r>
-              <a:t>- docs/PRODUCT_GUIDE.md — option intelligence and agent council</a:t>
+              <a:t>- docs/PRODUCT_GUIDE.md — option intelligence and Decision Memory</a:t>
             </a:r>
           </a:p>
           <a:p xmlns:a="http://schemas.openxmlformats.org/drawingml/2006/main">
             <a:r>
               <a:t>- lib/option-intelligence.ts — signal checks</a:t>
+            </a:r>
+          </a:p>
+          <a:p xmlns:a="http://schemas.openxmlformats.org/drawingml/2006/main">
+            <a:r>
+              <a:t>- lib/decision-memory.ts — 60-minute confirmation policy</a:t>
             </a:r>
           </a:p>
         </p:txBody>
@@ -627,7 +632,7 @@
           <a:lstStyle xmlns:a="http://schemas.openxmlformats.org/drawingml/2006/main"/>
           <a:p xmlns:a="http://schemas.openxmlformats.org/drawingml/2006/main">
             <a:r>
-              <a:t>A candidate still cannot trade. The constructor chooses exact defined-risk legs and prices buys at the ask and sells at the bid. Four transparent specialists test regime, volatility, catalysts, and failure modes. Then thirteen deterministic gates enforce paper mode, covered shorts, expiry, quote quality, confidence, drawdown, capacity, and the loss budget.</a:t>
+              <a:t>A candidate still cannot trade. The constructor chooses exact defined-risk legs and prices buys at the ask and sells at the bid. Five transparent specialists test regime, volatility, verified catalysts, recent decision memory, and failure modes. Memory requires two matching open-market observations within sixty minutes and at least sixty percent agreement. Then thirteen deterministic gates enforce paper mode, covered shorts, expiry, quote quality, confidence, drawdown, capacity, and the loss budget.</a:t>
             </a:r>
           </a:p>
           <a:p xmlns:a="http://schemas.openxmlformats.org/drawingml/2006/main">
@@ -652,7 +657,12 @@
           </a:p>
           <a:p xmlns:a="http://schemas.openxmlformats.org/drawingml/2006/main">
             <a:r>
-              <a:t>- lib/agent-council.ts — specialist votes</a:t>
+              <a:t>- lib/agent-council.ts — five specialist votes</a:t>
+            </a:r>
+          </a:p>
+          <a:p xmlns:a="http://schemas.openxmlformats.org/drawingml/2006/main">
+            <a:r>
+              <a:t>- lib/decision-memory.ts — confirmation policy</a:t>
             </a:r>
           </a:p>
         </p:txBody>
@@ -722,7 +732,7 @@
           <a:lstStyle xmlns:a="http://schemas.openxmlformats.org/drawingml/2006/main"/>
           <a:p xmlns:a="http://schemas.openxmlformats.org/drawingml/2006/main">
             <a:r>
-              <a:t>On September first, VolGuard selected the September fourth GLD 398–391 bear-put spread. The conservative limit was one dollar eighty-two, maximum loss was one hundred eighty-two dollars, and theoretical maximum expiration profit was five hundred eighteen dollars. The Alpaca dry run validated the atomic order, and the paper account filled at one dollar seventy-nine.</a:t>
+              <a:t>On September first, VolGuard selected the September fourth GLD 398–391 bear-put spread. The conservative limit was one dollar eighty-two, maximum loss was one hundred eighty-two dollars, and theoretical maximum expiration profit was five hundred eighteen dollars. The Alpaca dry run validated the atomic order, and the paper account filled at one dollar seventy-nine. This historical fill predates the Decision Memory gate; subsequent entries must also pass memory confirmation.</a:t>
             </a:r>
           </a:p>
           <a:p xmlns:a="http://schemas.openxmlformats.org/drawingml/2006/main">
@@ -743,6 +753,11 @@
           <a:p xmlns:a="http://schemas.openxmlformats.org/drawingml/2006/main">
             <a:r>
               <a:t>- Append-only paper order and lifecycle events in VolGuard telemetry</a:t>
+            </a:r>
+          </a:p>
+          <a:p xmlns:a="http://schemas.openxmlformats.org/drawingml/2006/main">
+            <a:r>
+              <a:t>- lib/decision-memory.ts — subsequent-entry confirmation policy</a:t>
             </a:r>
           </a:p>
         </p:txBody>
@@ -812,7 +827,7 @@
           <a:lstStyle xmlns:a="http://schemas.openxmlformats.org/drawingml/2006/main"/>
           <a:p xmlns:a="http://schemas.openxmlformats.org/drawingml/2006/main">
             <a:r>
-              <a:t>Every five minutes, a Cloudflare Worker dispatches an authenticated GitHub Actions monitor. It matches each strategy to the broker positions, gets fresh two-sided quotes, and independently applies a fifty-percent profit capture, a fifty-percent debit-loss limit, or a three-P-M Eastern prior-weekday time exit. If reconciliation or evidence fails, the system stops.</a:t>
+              <a:t>Every five minutes during the weekday New York session window, a Cloudflare Worker dispatches one authenticated GitHub Actions paper cycle. Every run reconciles broker state and independently evaluates each open strategy's profit, loss, and time exit. Every other run also refreshes the account, scans for an entry, and requires a matching D1 Decision Memory verdict. If reconciliation, evidence, memory, capacity, or policy fails, the system holds.</a:t>
             </a:r>
           </a:p>
           <a:p xmlns:a="http://schemas.openxmlformats.org/drawingml/2006/main">
@@ -827,12 +842,17 @@
           </a:p>
           <a:p xmlns:a="http://schemas.openxmlformats.org/drawingml/2006/main">
             <a:r>
-              <a:t>- workers/github-scheduler/wrangler.jsonc — schedule</a:t>
-            </a:r>
-          </a:p>
-          <a:p xmlns:a="http://schemas.openxmlformats.org/drawingml/2006/main">
-            <a:r>
-              <a:t>- .github/workflows/monitor-paper-position.yml — monitor workflow</a:t>
+              <a:t>- workers/github-scheduler/wrangler.jsonc — session-aware schedule</a:t>
+            </a:r>
+          </a:p>
+          <a:p xmlns:a="http://schemas.openxmlformats.org/drawingml/2006/main">
+            <a:r>
+              <a:t>- .github/workflows/monitor-paper-position.yml — serialized paper cycle</a:t>
+            </a:r>
+          </a:p>
+          <a:p xmlns:a="http://schemas.openxmlformats.org/drawingml/2006/main">
+            <a:r>
+              <a:t>- lib/decision-memory.ts — D1-backed confirmation</a:t>
             </a:r>
           </a:p>
           <a:p xmlns:a="http://schemas.openxmlformats.org/drawingml/2006/main">
@@ -995,7 +1015,7 @@
   </p:cSld>
   <p:clrMap bg1="lt1" tx1="dk1" bg2="lt2" tx2="dk2" accent1="accent1" accent2="accent2" accent3="accent3" accent4="accent4" accent5="accent5" accent6="accent6" hlink="hlink" folHlink="folHlink"/>
   <p:sldLayoutIdLst>
-    <p:sldLayoutId xmlns:r="http://schemas.openxmlformats.org/officeDocument/2006/relationships" id="2147483649" r:id="Rc4e2b4147a0140d3"/>
+    <p:sldLayoutId xmlns:r="http://schemas.openxmlformats.org/officeDocument/2006/relationships" id="2147483649" r:id="R6509e8a19fd6426b"/>
   </p:sldLayoutIdLst>
   <p:txStyles>
     <p:titleStyle>
@@ -1574,6 +1594,7 @@
           <a:lstStyle xmlns:a="http://schemas.openxmlformats.org/drawingml/2006/main"/>
           <a:p xmlns:a="http://schemas.openxmlformats.org/drawingml/2006/main">
             <a:pPr>
+              <a:buNone/>
               <a:defRPr sz="1125" b="1">
                 <a:solidFill>
                   <a:srgbClr val="3D8DFF"/>
@@ -1624,6 +1645,7 @@
           <a:lstStyle xmlns:a="http://schemas.openxmlformats.org/drawingml/2006/main"/>
           <a:p xmlns:a="http://schemas.openxmlformats.org/drawingml/2006/main">
             <a:pPr>
+              <a:buNone/>
               <a:defRPr sz="5100" b="1">
                 <a:solidFill>
                   <a:srgbClr val="0B1220"/>
@@ -1674,6 +1696,7 @@
           <a:lstStyle xmlns:a="http://schemas.openxmlformats.org/drawingml/2006/main"/>
           <a:p xmlns:a="http://schemas.openxmlformats.org/drawingml/2006/main">
             <a:pPr>
+              <a:buNone/>
               <a:defRPr sz="2100">
                 <a:solidFill>
                   <a:srgbClr val="596579"/>
@@ -1724,6 +1747,7 @@
           <a:lstStyle xmlns:a="http://schemas.openxmlformats.org/drawingml/2006/main"/>
           <a:p xmlns:a="http://schemas.openxmlformats.org/drawingml/2006/main">
             <a:pPr>
+              <a:buNone/>
               <a:defRPr sz="1200" b="1">
                 <a:solidFill>
                   <a:srgbClr val="19A974"/>
@@ -1774,6 +1798,7 @@
           <a:lstStyle xmlns:a="http://schemas.openxmlformats.org/drawingml/2006/main"/>
           <a:p xmlns:a="http://schemas.openxmlformats.org/drawingml/2006/main">
             <a:pPr>
+              <a:buNone/>
               <a:defRPr sz="1200">
                 <a:solidFill>
                   <a:srgbClr val="596579"/>
@@ -1859,6 +1884,7 @@
           <a:lstStyle xmlns:a="http://schemas.openxmlformats.org/drawingml/2006/main"/>
           <a:p xmlns:a="http://schemas.openxmlformats.org/drawingml/2006/main">
             <a:pPr>
+              <a:buNone/>
               <a:defRPr sz="1050" b="1">
                 <a:solidFill>
                   <a:srgbClr val="3D8DFF"/>
@@ -1878,14 +1904,14 @@
       </p:sp>
       <p:pic>
         <p:nvPicPr>
-          <p:cNvPr id="17" name=""/>
+          <p:cNvPr id="19" name=""/>
           <p:cNvPicPr>
             <a:picLocks xmlns:a="http://schemas.openxmlformats.org/drawingml/2006/main" noChangeAspect="1"/>
           </p:cNvPicPr>
           <p:nvPr/>
         </p:nvPicPr>
         <p:blipFill>
-          <a:blip xmlns:r="http://schemas.openxmlformats.org/officeDocument/2006/relationships" xmlns:a="http://schemas.openxmlformats.org/drawingml/2006/main" r:embed="Rcd5b69a1a3b142fd"/>
+          <a:blip xmlns:r="http://schemas.openxmlformats.org/officeDocument/2006/relationships" xmlns:a="http://schemas.openxmlformats.org/drawingml/2006/main" r:embed="R17e8c0af39fb42a8"/>
           <a:stretch xmlns:a="http://schemas.openxmlformats.org/drawingml/2006/main"/>
         </p:blipFill>
         <p:spPr>
@@ -1933,6 +1959,7 @@
           <a:lstStyle xmlns:a="http://schemas.openxmlformats.org/drawingml/2006/main"/>
           <a:p xmlns:a="http://schemas.openxmlformats.org/drawingml/2006/main">
             <a:pPr>
+              <a:buNone/>
               <a:defRPr sz="1200">
                 <a:solidFill>
                   <a:srgbClr val="596579"/>
@@ -2012,6 +2039,7 @@
           <a:lstStyle xmlns:a="http://schemas.openxmlformats.org/drawingml/2006/main"/>
           <a:p xmlns:a="http://schemas.openxmlformats.org/drawingml/2006/main">
             <a:pPr>
+              <a:buNone/>
               <a:defRPr sz="1050" b="1">
                 <a:solidFill>
                   <a:srgbClr val="3D8DFF"/>
@@ -2062,6 +2090,7 @@
           <a:lstStyle xmlns:a="http://schemas.openxmlformats.org/drawingml/2006/main"/>
           <a:p xmlns:a="http://schemas.openxmlformats.org/drawingml/2006/main">
             <a:pPr>
+              <a:buNone/>
               <a:defRPr sz="3150" b="1">
                 <a:solidFill>
                   <a:srgbClr val="0B1220"/>
@@ -2143,6 +2172,7 @@
           <a:lstStyle xmlns:a="http://schemas.openxmlformats.org/drawingml/2006/main"/>
           <a:p xmlns:a="http://schemas.openxmlformats.org/drawingml/2006/main">
             <a:pPr algn="r">
+              <a:buNone/>
               <a:defRPr sz="900">
                 <a:solidFill>
                   <a:srgbClr val="596579"/>
@@ -2393,6 +2423,7 @@
           <a:lstStyle xmlns:a="http://schemas.openxmlformats.org/drawingml/2006/main"/>
           <a:p xmlns:a="http://schemas.openxmlformats.org/drawingml/2006/main">
             <a:pPr>
+              <a:buNone/>
               <a:defRPr sz="1200" b="1">
                 <a:solidFill>
                   <a:srgbClr val="3D8DFF"/>
@@ -2443,6 +2474,7 @@
           <a:lstStyle xmlns:a="http://schemas.openxmlformats.org/drawingml/2006/main"/>
           <a:p xmlns:a="http://schemas.openxmlformats.org/drawingml/2006/main">
             <a:pPr>
+              <a:buNone/>
               <a:defRPr sz="1725" b="1">
                 <a:solidFill>
                   <a:srgbClr val="0B1220"/>
@@ -2493,6 +2525,7 @@
           <a:lstStyle xmlns:a="http://schemas.openxmlformats.org/drawingml/2006/main"/>
           <a:p xmlns:a="http://schemas.openxmlformats.org/drawingml/2006/main">
             <a:pPr>
+              <a:buNone/>
               <a:defRPr sz="1200">
                 <a:solidFill>
                   <a:srgbClr val="596579"/>
@@ -2510,6 +2543,7 @@
           </a:p>
           <a:p xmlns:a="http://schemas.openxmlformats.org/drawingml/2006/main">
             <a:pPr>
+              <a:buNone/>
               <a:defRPr sz="1200">
                 <a:solidFill>
                   <a:srgbClr val="596579"/>
@@ -2595,6 +2629,7 @@
           <a:lstStyle xmlns:a="http://schemas.openxmlformats.org/drawingml/2006/main"/>
           <a:p xmlns:a="http://schemas.openxmlformats.org/drawingml/2006/main">
             <a:pPr>
+              <a:buNone/>
               <a:defRPr sz="1200" b="1">
                 <a:solidFill>
                   <a:srgbClr val="3D8DFF"/>
@@ -2645,6 +2680,7 @@
           <a:lstStyle xmlns:a="http://schemas.openxmlformats.org/drawingml/2006/main"/>
           <a:p xmlns:a="http://schemas.openxmlformats.org/drawingml/2006/main">
             <a:pPr>
+              <a:buNone/>
               <a:defRPr sz="1725" b="1">
                 <a:solidFill>
                   <a:srgbClr val="0B1220"/>
@@ -2695,6 +2731,7 @@
           <a:lstStyle xmlns:a="http://schemas.openxmlformats.org/drawingml/2006/main"/>
           <a:p xmlns:a="http://schemas.openxmlformats.org/drawingml/2006/main">
             <a:pPr>
+              <a:buNone/>
               <a:defRPr sz="1200">
                 <a:solidFill>
                   <a:srgbClr val="596579"/>
@@ -2712,6 +2749,7 @@
           </a:p>
           <a:p xmlns:a="http://schemas.openxmlformats.org/drawingml/2006/main">
             <a:pPr>
+              <a:buNone/>
               <a:defRPr sz="1200">
                 <a:solidFill>
                   <a:srgbClr val="596579"/>
@@ -2797,6 +2835,7 @@
           <a:lstStyle xmlns:a="http://schemas.openxmlformats.org/drawingml/2006/main"/>
           <a:p xmlns:a="http://schemas.openxmlformats.org/drawingml/2006/main">
             <a:pPr>
+              <a:buNone/>
               <a:defRPr sz="1200" b="1">
                 <a:solidFill>
                   <a:srgbClr val="3D8DFF"/>
@@ -2847,6 +2886,7 @@
           <a:lstStyle xmlns:a="http://schemas.openxmlformats.org/drawingml/2006/main"/>
           <a:p xmlns:a="http://schemas.openxmlformats.org/drawingml/2006/main">
             <a:pPr>
+              <a:buNone/>
               <a:defRPr sz="1725" b="1">
                 <a:solidFill>
                   <a:srgbClr val="0B1220"/>
@@ -2897,6 +2937,7 @@
           <a:lstStyle xmlns:a="http://schemas.openxmlformats.org/drawingml/2006/main"/>
           <a:p xmlns:a="http://schemas.openxmlformats.org/drawingml/2006/main">
             <a:pPr>
+              <a:buNone/>
               <a:defRPr sz="1200">
                 <a:solidFill>
                   <a:srgbClr val="596579"/>
@@ -2914,6 +2955,7 @@
           </a:p>
           <a:p xmlns:a="http://schemas.openxmlformats.org/drawingml/2006/main">
             <a:pPr>
+              <a:buNone/>
               <a:defRPr sz="1200">
                 <a:solidFill>
                   <a:srgbClr val="596579"/>
@@ -2999,6 +3041,7 @@
           <a:lstStyle xmlns:a="http://schemas.openxmlformats.org/drawingml/2006/main"/>
           <a:p xmlns:a="http://schemas.openxmlformats.org/drawingml/2006/main">
             <a:pPr>
+              <a:buNone/>
               <a:defRPr sz="1200" b="1">
                 <a:solidFill>
                   <a:srgbClr val="3D8DFF"/>
@@ -3049,6 +3092,7 @@
           <a:lstStyle xmlns:a="http://schemas.openxmlformats.org/drawingml/2006/main"/>
           <a:p xmlns:a="http://schemas.openxmlformats.org/drawingml/2006/main">
             <a:pPr>
+              <a:buNone/>
               <a:defRPr sz="1725" b="1">
                 <a:solidFill>
                   <a:srgbClr val="0B1220"/>
@@ -3099,6 +3143,7 @@
           <a:lstStyle xmlns:a="http://schemas.openxmlformats.org/drawingml/2006/main"/>
           <a:p xmlns:a="http://schemas.openxmlformats.org/drawingml/2006/main">
             <a:pPr>
+              <a:buNone/>
               <a:defRPr sz="1200">
                 <a:solidFill>
                   <a:srgbClr val="596579"/>
@@ -3116,6 +3161,7 @@
           </a:p>
           <a:p xmlns:a="http://schemas.openxmlformats.org/drawingml/2006/main">
             <a:pPr>
+              <a:buNone/>
               <a:defRPr sz="1200">
                 <a:solidFill>
                   <a:srgbClr val="596579"/>
@@ -3201,6 +3247,7 @@
           <a:lstStyle xmlns:a="http://schemas.openxmlformats.org/drawingml/2006/main"/>
           <a:p xmlns:a="http://schemas.openxmlformats.org/drawingml/2006/main">
             <a:pPr>
+              <a:buNone/>
               <a:defRPr sz="1200" b="1">
                 <a:solidFill>
                   <a:srgbClr val="3D8DFF"/>
@@ -3251,6 +3298,7 @@
           <a:lstStyle xmlns:a="http://schemas.openxmlformats.org/drawingml/2006/main"/>
           <a:p xmlns:a="http://schemas.openxmlformats.org/drawingml/2006/main">
             <a:pPr>
+              <a:buNone/>
               <a:defRPr sz="1725" b="1">
                 <a:solidFill>
                   <a:srgbClr val="0B1220"/>
@@ -3301,6 +3349,7 @@
           <a:lstStyle xmlns:a="http://schemas.openxmlformats.org/drawingml/2006/main"/>
           <a:p xmlns:a="http://schemas.openxmlformats.org/drawingml/2006/main">
             <a:pPr>
+              <a:buNone/>
               <a:defRPr sz="1200">
                 <a:solidFill>
                   <a:srgbClr val="596579"/>
@@ -3313,11 +3362,20 @@
                   <a:srgbClr val="596579"/>
                 </a:solidFill>
               </a:rPr>
-              <a:t>Four transparent</a:t>
-            </a:r>
-          </a:p>
-          <a:p xmlns:a="http://schemas.openxmlformats.org/drawingml/2006/main">
-            <a:pPr>
+              <a:t>Five</a:t>
+            </a:r>
+            <a:r>
+              <a:rPr sz="1200">
+                <a:solidFill>
+                  <a:srgbClr val="596579"/>
+                </a:solidFill>
+              </a:rPr>
+              <a:t> transparent</a:t>
+            </a:r>
+          </a:p>
+          <a:p xmlns:a="http://schemas.openxmlformats.org/drawingml/2006/main">
+            <a:pPr>
+              <a:buNone/>
               <a:defRPr sz="1200">
                 <a:solidFill>
                   <a:srgbClr val="596579"/>
@@ -3403,6 +3461,7 @@
           <a:lstStyle xmlns:a="http://schemas.openxmlformats.org/drawingml/2006/main"/>
           <a:p xmlns:a="http://schemas.openxmlformats.org/drawingml/2006/main">
             <a:pPr>
+              <a:buNone/>
               <a:defRPr sz="1200" b="1">
                 <a:solidFill>
                   <a:srgbClr val="19A974"/>
@@ -3453,6 +3512,7 @@
           <a:lstStyle xmlns:a="http://schemas.openxmlformats.org/drawingml/2006/main"/>
           <a:p xmlns:a="http://schemas.openxmlformats.org/drawingml/2006/main">
             <a:pPr>
+              <a:buNone/>
               <a:defRPr sz="1725" b="1">
                 <a:solidFill>
                   <a:srgbClr val="0B1220"/>
@@ -3503,6 +3563,7 @@
           <a:lstStyle xmlns:a="http://schemas.openxmlformats.org/drawingml/2006/main"/>
           <a:p xmlns:a="http://schemas.openxmlformats.org/drawingml/2006/main">
             <a:pPr>
+              <a:buNone/>
               <a:defRPr sz="1200">
                 <a:solidFill>
                   <a:srgbClr val="596579"/>
@@ -3520,6 +3581,7 @@
           </a:p>
           <a:p xmlns:a="http://schemas.openxmlformats.org/drawingml/2006/main">
             <a:pPr>
+              <a:buNone/>
               <a:defRPr sz="1200">
                 <a:solidFill>
                   <a:srgbClr val="596579"/>
@@ -3570,6 +3632,7 @@
           <a:lstStyle xmlns:a="http://schemas.openxmlformats.org/drawingml/2006/main"/>
           <a:p xmlns:a="http://schemas.openxmlformats.org/drawingml/2006/main">
             <a:pPr>
+              <a:buNone/>
               <a:defRPr sz="2250" b="1">
                 <a:solidFill>
                   <a:srgbClr val="0B1220"/>
@@ -3620,6 +3683,7 @@
           <a:lstStyle xmlns:a="http://schemas.openxmlformats.org/drawingml/2006/main"/>
           <a:p xmlns:a="http://schemas.openxmlformats.org/drawingml/2006/main">
             <a:pPr>
+              <a:buNone/>
               <a:defRPr sz="1500">
                 <a:solidFill>
                   <a:srgbClr val="596579"/>
@@ -3699,6 +3763,7 @@
           <a:lstStyle xmlns:a="http://schemas.openxmlformats.org/drawingml/2006/main"/>
           <a:p xmlns:a="http://schemas.openxmlformats.org/drawingml/2006/main">
             <a:pPr>
+              <a:buNone/>
               <a:defRPr sz="1050" b="1">
                 <a:solidFill>
                   <a:srgbClr val="3D8DFF"/>
@@ -3749,6 +3814,7 @@
           <a:lstStyle xmlns:a="http://schemas.openxmlformats.org/drawingml/2006/main"/>
           <a:p xmlns:a="http://schemas.openxmlformats.org/drawingml/2006/main">
             <a:pPr>
+              <a:buNone/>
               <a:defRPr sz="3150" b="1">
                 <a:solidFill>
                   <a:srgbClr val="0B1220"/>
@@ -3830,6 +3896,7 @@
           <a:lstStyle xmlns:a="http://schemas.openxmlformats.org/drawingml/2006/main"/>
           <a:p xmlns:a="http://schemas.openxmlformats.org/drawingml/2006/main">
             <a:pPr algn="r">
+              <a:buNone/>
               <a:defRPr sz="900">
                 <a:solidFill>
                   <a:srgbClr val="596579"/>
@@ -3880,6 +3947,7 @@
           <a:lstStyle xmlns:a="http://schemas.openxmlformats.org/drawingml/2006/main"/>
           <a:p xmlns:a="http://schemas.openxmlformats.org/drawingml/2006/main">
             <a:pPr>
+              <a:buNone/>
               <a:defRPr sz="1575">
                 <a:solidFill>
                   <a:srgbClr val="596579"/>
@@ -3965,6 +4033,7 @@
           <a:lstStyle xmlns:a="http://schemas.openxmlformats.org/drawingml/2006/main"/>
           <a:p xmlns:a="http://schemas.openxmlformats.org/drawingml/2006/main">
             <a:pPr>
+              <a:buNone/>
               <a:defRPr sz="4050" b="1">
                 <a:solidFill>
                   <a:srgbClr val="3D8DFF"/>
@@ -4015,6 +4084,7 @@
           <a:lstStyle xmlns:a="http://schemas.openxmlformats.org/drawingml/2006/main"/>
           <a:p xmlns:a="http://schemas.openxmlformats.org/drawingml/2006/main">
             <a:pPr>
+              <a:buNone/>
               <a:defRPr sz="1650" b="1">
                 <a:solidFill>
                   <a:srgbClr val="0B1220"/>
@@ -4065,6 +4135,7 @@
           <a:lstStyle xmlns:a="http://schemas.openxmlformats.org/drawingml/2006/main"/>
           <a:p xmlns:a="http://schemas.openxmlformats.org/drawingml/2006/main">
             <a:pPr>
+              <a:buNone/>
               <a:defRPr sz="1275">
                 <a:solidFill>
                   <a:srgbClr val="596579"/>
@@ -4150,6 +4221,7 @@
           <a:lstStyle xmlns:a="http://schemas.openxmlformats.org/drawingml/2006/main"/>
           <a:p xmlns:a="http://schemas.openxmlformats.org/drawingml/2006/main">
             <a:pPr>
+              <a:buNone/>
               <a:defRPr sz="4050" b="1">
                 <a:solidFill>
                   <a:srgbClr val="0B1220"/>
@@ -4200,6 +4272,7 @@
           <a:lstStyle xmlns:a="http://schemas.openxmlformats.org/drawingml/2006/main"/>
           <a:p xmlns:a="http://schemas.openxmlformats.org/drawingml/2006/main">
             <a:pPr>
+              <a:buNone/>
               <a:defRPr sz="1650" b="1">
                 <a:solidFill>
                   <a:srgbClr val="0B1220"/>
@@ -4250,6 +4323,7 @@
           <a:lstStyle xmlns:a="http://schemas.openxmlformats.org/drawingml/2006/main"/>
           <a:p xmlns:a="http://schemas.openxmlformats.org/drawingml/2006/main">
             <a:pPr>
+              <a:buNone/>
               <a:defRPr sz="1275">
                 <a:solidFill>
                   <a:srgbClr val="596579"/>
@@ -4335,6 +4409,7 @@
           <a:lstStyle xmlns:a="http://schemas.openxmlformats.org/drawingml/2006/main"/>
           <a:p xmlns:a="http://schemas.openxmlformats.org/drawingml/2006/main">
             <a:pPr>
+              <a:buNone/>
               <a:defRPr sz="4050" b="1">
                 <a:solidFill>
                   <a:srgbClr val="0B1220"/>
@@ -4385,6 +4460,7 @@
           <a:lstStyle xmlns:a="http://schemas.openxmlformats.org/drawingml/2006/main"/>
           <a:p xmlns:a="http://schemas.openxmlformats.org/drawingml/2006/main">
             <a:pPr>
+              <a:buNone/>
               <a:defRPr sz="1650" b="1">
                 <a:solidFill>
                   <a:srgbClr val="0B1220"/>
@@ -4435,6 +4511,7 @@
           <a:lstStyle xmlns:a="http://schemas.openxmlformats.org/drawingml/2006/main"/>
           <a:p xmlns:a="http://schemas.openxmlformats.org/drawingml/2006/main">
             <a:pPr>
+              <a:buNone/>
               <a:defRPr sz="1275">
                 <a:solidFill>
                   <a:srgbClr val="596579"/>
@@ -4485,6 +4562,7 @@
           <a:lstStyle xmlns:a="http://schemas.openxmlformats.org/drawingml/2006/main"/>
           <a:p xmlns:a="http://schemas.openxmlformats.org/drawingml/2006/main">
             <a:pPr>
+              <a:buNone/>
               <a:defRPr sz="1350" b="1">
                 <a:solidFill>
                   <a:srgbClr val="0B1220"/>
@@ -4535,6 +4613,7 @@
           <a:lstStyle xmlns:a="http://schemas.openxmlformats.org/drawingml/2006/main"/>
           <a:p xmlns:a="http://schemas.openxmlformats.org/drawingml/2006/main">
             <a:pPr>
+              <a:buNone/>
               <a:defRPr sz="1350" b="1">
                 <a:solidFill>
                   <a:srgbClr val="0B1220"/>
@@ -4585,6 +4664,7 @@
           <a:lstStyle xmlns:a="http://schemas.openxmlformats.org/drawingml/2006/main"/>
           <a:p xmlns:a="http://schemas.openxmlformats.org/drawingml/2006/main">
             <a:pPr>
+              <a:buNone/>
               <a:defRPr sz="1500" b="1">
                 <a:solidFill>
                   <a:srgbClr val="C73E4D"/>
@@ -4597,7 +4677,7 @@
                   <a:srgbClr val="C73E4D"/>
                 </a:solidFill>
               </a:rPr>
-              <a:t>Any mismatch, stale quote, or red-team veto stops the workflow.</a:t>
+              <a:t>Any mismatch, stale quote, memory conflict, or red-team veto stops the workflow.</a:t>
             </a:r>
           </a:p>
         </p:txBody>
@@ -4664,6 +4744,7 @@
           <a:lstStyle xmlns:a="http://schemas.openxmlformats.org/drawingml/2006/main"/>
           <a:p xmlns:a="http://schemas.openxmlformats.org/drawingml/2006/main">
             <a:pPr>
+              <a:buNone/>
               <a:defRPr sz="1050" b="1">
                 <a:solidFill>
                   <a:srgbClr val="3D8DFF"/>
@@ -4714,6 +4795,7 @@
           <a:lstStyle xmlns:a="http://schemas.openxmlformats.org/drawingml/2006/main"/>
           <a:p xmlns:a="http://schemas.openxmlformats.org/drawingml/2006/main">
             <a:pPr>
+              <a:buNone/>
               <a:defRPr sz="3150" b="1">
                 <a:solidFill>
                   <a:srgbClr val="0B1220"/>
@@ -4795,6 +4877,7 @@
           <a:lstStyle xmlns:a="http://schemas.openxmlformats.org/drawingml/2006/main"/>
           <a:p xmlns:a="http://schemas.openxmlformats.org/drawingml/2006/main">
             <a:pPr algn="r">
+              <a:buNone/>
               <a:defRPr sz="900">
                 <a:solidFill>
                   <a:srgbClr val="596579"/>
@@ -4845,6 +4928,7 @@
           <a:lstStyle xmlns:a="http://schemas.openxmlformats.org/drawingml/2006/main"/>
           <a:p xmlns:a="http://schemas.openxmlformats.org/drawingml/2006/main">
             <a:pPr>
+              <a:buNone/>
               <a:defRPr sz="4350" b="1">
                 <a:solidFill>
                   <a:srgbClr val="3D8DFF"/>
@@ -4895,6 +4979,7 @@
           <a:lstStyle xmlns:a="http://schemas.openxmlformats.org/drawingml/2006/main"/>
           <a:p xmlns:a="http://schemas.openxmlformats.org/drawingml/2006/main">
             <a:pPr>
+              <a:buNone/>
               <a:defRPr sz="1650" b="1">
                 <a:solidFill>
                   <a:srgbClr val="0B1220"/>
@@ -4945,6 +5030,7 @@
           <a:lstStyle xmlns:a="http://schemas.openxmlformats.org/drawingml/2006/main"/>
           <a:p xmlns:a="http://schemas.openxmlformats.org/drawingml/2006/main">
             <a:pPr>
+              <a:buNone/>
               <a:defRPr sz="1875" b="1">
                 <a:solidFill>
                   <a:srgbClr val="0B1220"/>
@@ -4995,6 +5081,7 @@
           <a:lstStyle xmlns:a="http://schemas.openxmlformats.org/drawingml/2006/main"/>
           <a:p xmlns:a="http://schemas.openxmlformats.org/drawingml/2006/main">
             <a:pPr>
+              <a:buNone/>
               <a:defRPr sz="1875" b="1">
                 <a:solidFill>
                   <a:srgbClr val="0B1220"/>
@@ -5080,6 +5167,7 @@
           <a:lstStyle xmlns:a="http://schemas.openxmlformats.org/drawingml/2006/main"/>
           <a:p xmlns:a="http://schemas.openxmlformats.org/drawingml/2006/main">
             <a:pPr>
+              <a:buNone/>
               <a:defRPr sz="2100" b="1">
                 <a:solidFill>
                   <a:srgbClr val="0B1220"/>
@@ -5130,6 +5218,7 @@
           <a:lstStyle xmlns:a="http://schemas.openxmlformats.org/drawingml/2006/main"/>
           <a:p xmlns:a="http://schemas.openxmlformats.org/drawingml/2006/main">
             <a:pPr>
+              <a:buNone/>
               <a:defRPr sz="2100" b="1">
                 <a:solidFill>
                   <a:srgbClr val="19A974"/>
@@ -5180,6 +5269,7 @@
           <a:lstStyle xmlns:a="http://schemas.openxmlformats.org/drawingml/2006/main"/>
           <a:p xmlns:a="http://schemas.openxmlformats.org/drawingml/2006/main">
             <a:pPr>
+              <a:buNone/>
               <a:defRPr sz="1350">
                 <a:solidFill>
                   <a:srgbClr val="596579"/>
@@ -5294,6 +5384,7 @@
           <a:lstStyle xmlns:a="http://schemas.openxmlformats.org/drawingml/2006/main"/>
           <a:p xmlns:a="http://schemas.openxmlformats.org/drawingml/2006/main">
             <a:pPr algn="ctr">
+              <a:buNone/>
               <a:defRPr sz="1050" b="1">
                 <a:solidFill>
                   <a:srgbClr val="3D8DFF"/>
@@ -5344,6 +5435,7 @@
           <a:lstStyle xmlns:a="http://schemas.openxmlformats.org/drawingml/2006/main"/>
           <a:p xmlns:a="http://schemas.openxmlformats.org/drawingml/2006/main">
             <a:pPr>
+              <a:buNone/>
               <a:defRPr sz="1500" b="1">
                 <a:solidFill>
                   <a:srgbClr val="0B1220"/>
@@ -5394,6 +5486,7 @@
           <a:lstStyle xmlns:a="http://schemas.openxmlformats.org/drawingml/2006/main"/>
           <a:p xmlns:a="http://schemas.openxmlformats.org/drawingml/2006/main">
             <a:pPr>
+              <a:buNone/>
               <a:defRPr sz="1200">
                 <a:solidFill>
                   <a:srgbClr val="596579"/>
@@ -5477,6 +5570,7 @@
           <a:lstStyle xmlns:a="http://schemas.openxmlformats.org/drawingml/2006/main"/>
           <a:p xmlns:a="http://schemas.openxmlformats.org/drawingml/2006/main">
             <a:pPr algn="ctr">
+              <a:buNone/>
               <a:defRPr sz="1050" b="1">
                 <a:solidFill>
                   <a:srgbClr val="3D8DFF"/>
@@ -5527,6 +5621,7 @@
           <a:lstStyle xmlns:a="http://schemas.openxmlformats.org/drawingml/2006/main"/>
           <a:p xmlns:a="http://schemas.openxmlformats.org/drawingml/2006/main">
             <a:pPr>
+              <a:buNone/>
               <a:defRPr sz="1500" b="1">
                 <a:solidFill>
                   <a:srgbClr val="0B1220"/>
@@ -5577,6 +5672,7 @@
           <a:lstStyle xmlns:a="http://schemas.openxmlformats.org/drawingml/2006/main"/>
           <a:p xmlns:a="http://schemas.openxmlformats.org/drawingml/2006/main">
             <a:pPr>
+              <a:buNone/>
               <a:defRPr sz="1200">
                 <a:solidFill>
                   <a:srgbClr val="596579"/>
@@ -5660,6 +5756,7 @@
           <a:lstStyle xmlns:a="http://schemas.openxmlformats.org/drawingml/2006/main"/>
           <a:p xmlns:a="http://schemas.openxmlformats.org/drawingml/2006/main">
             <a:pPr algn="ctr">
+              <a:buNone/>
               <a:defRPr sz="1050" b="1">
                 <a:solidFill>
                   <a:srgbClr val="3D8DFF"/>
@@ -5710,6 +5807,7 @@
           <a:lstStyle xmlns:a="http://schemas.openxmlformats.org/drawingml/2006/main"/>
           <a:p xmlns:a="http://schemas.openxmlformats.org/drawingml/2006/main">
             <a:pPr>
+              <a:buNone/>
               <a:defRPr sz="1500" b="1">
                 <a:solidFill>
                   <a:srgbClr val="0B1220"/>
@@ -5760,6 +5858,7 @@
           <a:lstStyle xmlns:a="http://schemas.openxmlformats.org/drawingml/2006/main"/>
           <a:p xmlns:a="http://schemas.openxmlformats.org/drawingml/2006/main">
             <a:pPr>
+              <a:buNone/>
               <a:defRPr sz="1200">
                 <a:solidFill>
                   <a:srgbClr val="596579"/>
@@ -5843,6 +5942,7 @@
           <a:lstStyle xmlns:a="http://schemas.openxmlformats.org/drawingml/2006/main"/>
           <a:p xmlns:a="http://schemas.openxmlformats.org/drawingml/2006/main">
             <a:pPr algn="ctr">
+              <a:buNone/>
               <a:defRPr sz="1050" b="1">
                 <a:solidFill>
                   <a:srgbClr val="3D8DFF"/>
@@ -5893,6 +5993,7 @@
           <a:lstStyle xmlns:a="http://schemas.openxmlformats.org/drawingml/2006/main"/>
           <a:p xmlns:a="http://schemas.openxmlformats.org/drawingml/2006/main">
             <a:pPr>
+              <a:buNone/>
               <a:defRPr sz="1500" b="1">
                 <a:solidFill>
                   <a:srgbClr val="0B1220"/>
@@ -5943,6 +6044,7 @@
           <a:lstStyle xmlns:a="http://schemas.openxmlformats.org/drawingml/2006/main"/>
           <a:p xmlns:a="http://schemas.openxmlformats.org/drawingml/2006/main">
             <a:pPr>
+              <a:buNone/>
               <a:defRPr sz="1200">
                 <a:solidFill>
                   <a:srgbClr val="596579"/>
@@ -6026,6 +6128,7 @@
           <a:lstStyle xmlns:a="http://schemas.openxmlformats.org/drawingml/2006/main"/>
           <a:p xmlns:a="http://schemas.openxmlformats.org/drawingml/2006/main">
             <a:pPr algn="ctr">
+              <a:buNone/>
               <a:defRPr sz="1050" b="1">
                 <a:solidFill>
                   <a:srgbClr val="19A974"/>
@@ -6076,6 +6179,7 @@
           <a:lstStyle xmlns:a="http://schemas.openxmlformats.org/drawingml/2006/main"/>
           <a:p xmlns:a="http://schemas.openxmlformats.org/drawingml/2006/main">
             <a:pPr>
+              <a:buNone/>
               <a:defRPr sz="1500" b="1">
                 <a:solidFill>
                   <a:srgbClr val="0B1220"/>
@@ -6126,6 +6230,7 @@
           <a:lstStyle xmlns:a="http://schemas.openxmlformats.org/drawingml/2006/main"/>
           <a:p xmlns:a="http://schemas.openxmlformats.org/drawingml/2006/main">
             <a:pPr>
+              <a:buNone/>
               <a:defRPr sz="1200">
                 <a:solidFill>
                   <a:srgbClr val="596579"/>
@@ -6205,6 +6310,7 @@
           <a:lstStyle xmlns:a="http://schemas.openxmlformats.org/drawingml/2006/main"/>
           <a:p xmlns:a="http://schemas.openxmlformats.org/drawingml/2006/main">
             <a:pPr>
+              <a:buNone/>
               <a:defRPr sz="1050" b="1">
                 <a:solidFill>
                   <a:srgbClr val="3D8DFF"/>
@@ -6255,6 +6361,7 @@
           <a:lstStyle xmlns:a="http://schemas.openxmlformats.org/drawingml/2006/main"/>
           <a:p xmlns:a="http://schemas.openxmlformats.org/drawingml/2006/main">
             <a:pPr>
+              <a:buNone/>
               <a:defRPr sz="3150" b="1">
                 <a:solidFill>
                   <a:srgbClr val="0B1220"/>
@@ -6336,6 +6443,7 @@
           <a:lstStyle xmlns:a="http://schemas.openxmlformats.org/drawingml/2006/main"/>
           <a:p xmlns:a="http://schemas.openxmlformats.org/drawingml/2006/main">
             <a:pPr algn="r">
+              <a:buNone/>
               <a:defRPr sz="900">
                 <a:solidFill>
                   <a:srgbClr val="596579"/>
@@ -6520,6 +6628,7 @@
           <a:lstStyle xmlns:a="http://schemas.openxmlformats.org/drawingml/2006/main"/>
           <a:p xmlns:a="http://schemas.openxmlformats.org/drawingml/2006/main">
             <a:pPr>
+              <a:buNone/>
               <a:defRPr sz="1050" b="1">
                 <a:solidFill>
                   <a:srgbClr val="3D8DFF"/>
@@ -6570,6 +6679,7 @@
           <a:lstStyle xmlns:a="http://schemas.openxmlformats.org/drawingml/2006/main"/>
           <a:p xmlns:a="http://schemas.openxmlformats.org/drawingml/2006/main">
             <a:pPr>
+              <a:buNone/>
               <a:defRPr sz="1650" b="1">
                 <a:solidFill>
                   <a:srgbClr val="0B1220"/>
@@ -6620,6 +6730,7 @@
           <a:lstStyle xmlns:a="http://schemas.openxmlformats.org/drawingml/2006/main"/>
           <a:p xmlns:a="http://schemas.openxmlformats.org/drawingml/2006/main">
             <a:pPr>
+              <a:buNone/>
               <a:defRPr sz="1200">
                 <a:solidFill>
                   <a:srgbClr val="596579"/>
@@ -6705,6 +6816,7 @@
           <a:lstStyle xmlns:a="http://schemas.openxmlformats.org/drawingml/2006/main"/>
           <a:p xmlns:a="http://schemas.openxmlformats.org/drawingml/2006/main">
             <a:pPr>
+              <a:buNone/>
               <a:defRPr sz="1050" b="1">
                 <a:solidFill>
                   <a:srgbClr val="3D8DFF"/>
@@ -6755,6 +6867,7 @@
           <a:lstStyle xmlns:a="http://schemas.openxmlformats.org/drawingml/2006/main"/>
           <a:p xmlns:a="http://schemas.openxmlformats.org/drawingml/2006/main">
             <a:pPr>
+              <a:buNone/>
               <a:defRPr sz="1650" b="1">
                 <a:solidFill>
                   <a:srgbClr val="0B1220"/>
@@ -6805,6 +6918,7 @@
           <a:lstStyle xmlns:a="http://schemas.openxmlformats.org/drawingml/2006/main"/>
           <a:p xmlns:a="http://schemas.openxmlformats.org/drawingml/2006/main">
             <a:pPr>
+              <a:buNone/>
               <a:defRPr sz="1200">
                 <a:solidFill>
                   <a:srgbClr val="596579"/>
@@ -6890,6 +7004,7 @@
           <a:lstStyle xmlns:a="http://schemas.openxmlformats.org/drawingml/2006/main"/>
           <a:p xmlns:a="http://schemas.openxmlformats.org/drawingml/2006/main">
             <a:pPr>
+              <a:buNone/>
               <a:defRPr sz="1050" b="1">
                 <a:solidFill>
                   <a:srgbClr val="3D8DFF"/>
@@ -6940,6 +7055,7 @@
           <a:lstStyle xmlns:a="http://schemas.openxmlformats.org/drawingml/2006/main"/>
           <a:p xmlns:a="http://schemas.openxmlformats.org/drawingml/2006/main">
             <a:pPr>
+              <a:buNone/>
               <a:defRPr sz="1650" b="1">
                 <a:solidFill>
                   <a:srgbClr val="0B1220"/>
@@ -6990,6 +7106,7 @@
           <a:lstStyle xmlns:a="http://schemas.openxmlformats.org/drawingml/2006/main"/>
           <a:p xmlns:a="http://schemas.openxmlformats.org/drawingml/2006/main">
             <a:pPr>
+              <a:buNone/>
               <a:defRPr sz="1200">
                 <a:solidFill>
                   <a:srgbClr val="596579"/>
@@ -7075,6 +7192,7 @@
           <a:lstStyle xmlns:a="http://schemas.openxmlformats.org/drawingml/2006/main"/>
           <a:p xmlns:a="http://schemas.openxmlformats.org/drawingml/2006/main">
             <a:pPr>
+              <a:buNone/>
               <a:defRPr sz="1050" b="1">
                 <a:solidFill>
                   <a:srgbClr val="3D8DFF"/>
@@ -7125,6 +7243,7 @@
           <a:lstStyle xmlns:a="http://schemas.openxmlformats.org/drawingml/2006/main"/>
           <a:p xmlns:a="http://schemas.openxmlformats.org/drawingml/2006/main">
             <a:pPr>
+              <a:buNone/>
               <a:defRPr sz="1650" b="1">
                 <a:solidFill>
                   <a:srgbClr val="0B1220"/>
@@ -7175,6 +7294,7 @@
           <a:lstStyle xmlns:a="http://schemas.openxmlformats.org/drawingml/2006/main"/>
           <a:p xmlns:a="http://schemas.openxmlformats.org/drawingml/2006/main">
             <a:pPr>
+              <a:buNone/>
               <a:defRPr sz="1200">
                 <a:solidFill>
                   <a:srgbClr val="596579"/>
@@ -7187,7 +7307,7 @@
                   <a:srgbClr val="596579"/>
                 </a:solidFill>
               </a:rPr>
-              <a:t>Five responsive pages</a:t>
+              <a:t>Six responsive pages</a:t>
             </a:r>
           </a:p>
         </p:txBody>
@@ -7260,6 +7380,7 @@
           <a:lstStyle xmlns:a="http://schemas.openxmlformats.org/drawingml/2006/main"/>
           <a:p xmlns:a="http://schemas.openxmlformats.org/drawingml/2006/main">
             <a:pPr>
+              <a:buNone/>
               <a:defRPr sz="1800" b="1">
                 <a:solidFill>
                   <a:srgbClr val="19A974"/>
@@ -7272,7 +7393,7 @@
                   <a:srgbClr val="19A974"/>
                 </a:solidFill>
               </a:rPr>
-              <a:t>Cloudflare Worker  →  GitHub Actions  →  closing-only monitor</a:t>
+              <a:t>Cloudflare Worker  →  GitHub Actions  →  serialized paper cycle</a:t>
             </a:r>
           </a:p>
         </p:txBody>
@@ -7310,6 +7431,7 @@
           <a:lstStyle xmlns:a="http://schemas.openxmlformats.org/drawingml/2006/main"/>
           <a:p xmlns:a="http://schemas.openxmlformats.org/drawingml/2006/main">
             <a:pPr>
+              <a:buNone/>
               <a:defRPr sz="1275">
                 <a:solidFill>
                   <a:srgbClr val="596579"/>
@@ -7322,7 +7444,7 @@
                   <a:srgbClr val="596579"/>
                 </a:solidFill>
               </a:rPr>
-              <a:t>Every 5 minutes on trading weekdays: broker match, fresh two-sided quotes, independent profit/loss/time exits.</a:t>
+              <a:t>Every 5 minutes: reconcile + monitor exits. Every 10 minutes: fresh scan + memory-confirmed entry attempt.</a:t>
             </a:r>
           </a:p>
         </p:txBody>
@@ -7360,6 +7482,7 @@
           <a:lstStyle xmlns:a="http://schemas.openxmlformats.org/drawingml/2006/main"/>
           <a:p xmlns:a="http://schemas.openxmlformats.org/drawingml/2006/main">
             <a:pPr algn="ctr">
+              <a:buNone/>
               <a:defRPr sz="1200" b="1">
                 <a:solidFill>
                   <a:srgbClr val="C73E4D"/>
@@ -7439,6 +7562,7 @@
           <a:lstStyle xmlns:a="http://schemas.openxmlformats.org/drawingml/2006/main"/>
           <a:p xmlns:a="http://schemas.openxmlformats.org/drawingml/2006/main">
             <a:pPr>
+              <a:buNone/>
               <a:defRPr sz="1200" b="1">
                 <a:solidFill>
                   <a:srgbClr val="7FC3FF"/>
@@ -7489,6 +7613,7 @@
           <a:lstStyle xmlns:a="http://schemas.openxmlformats.org/drawingml/2006/main"/>
           <a:p xmlns:a="http://schemas.openxmlformats.org/drawingml/2006/main">
             <a:pPr>
+              <a:buNone/>
               <a:defRPr sz="4650" b="1">
                 <a:solidFill>
                   <a:srgbClr val="FFFFFF"/>
@@ -7539,6 +7664,7 @@
           <a:lstStyle xmlns:a="http://schemas.openxmlformats.org/drawingml/2006/main"/>
           <a:p xmlns:a="http://schemas.openxmlformats.org/drawingml/2006/main">
             <a:pPr>
+              <a:buNone/>
               <a:defRPr sz="2175" b="1">
                 <a:solidFill>
                   <a:srgbClr val="FFFFFF"/>
@@ -7589,6 +7715,7 @@
           <a:lstStyle xmlns:a="http://schemas.openxmlformats.org/drawingml/2006/main"/>
           <a:p xmlns:a="http://schemas.openxmlformats.org/drawingml/2006/main">
             <a:pPr>
+              <a:buNone/>
               <a:defRPr sz="2175" b="1">
                 <a:solidFill>
                   <a:srgbClr val="FFFFFF"/>
@@ -7639,6 +7766,7 @@
           <a:lstStyle xmlns:a="http://schemas.openxmlformats.org/drawingml/2006/main"/>
           <a:p xmlns:a="http://schemas.openxmlformats.org/drawingml/2006/main">
             <a:pPr>
+              <a:buNone/>
               <a:defRPr sz="2175" b="1">
                 <a:solidFill>
                   <a:srgbClr val="7FC3FF"/>
@@ -7689,6 +7817,7 @@
           <a:lstStyle xmlns:a="http://schemas.openxmlformats.org/drawingml/2006/main"/>
           <a:p xmlns:a="http://schemas.openxmlformats.org/drawingml/2006/main">
             <a:pPr>
+              <a:buNone/>
               <a:defRPr sz="1350">
                 <a:solidFill>
                   <a:srgbClr val="B8C4D6"/>
@@ -7739,6 +7868,7 @@
           <a:lstStyle xmlns:a="http://schemas.openxmlformats.org/drawingml/2006/main"/>
           <a:p xmlns:a="http://schemas.openxmlformats.org/drawingml/2006/main">
             <a:pPr algn="ctr">
+              <a:buNone/>
               <a:defRPr sz="8400" b="1">
                 <a:solidFill>
                   <a:srgbClr val="3D8DFF"/>

</xml_diff>